<commit_message>
#2 update presentation, fix typo
</commit_message>
<xml_diff>
--- a/presentations/20260313-presentation01.pptx
+++ b/presentations/20260313-presentation01.pptx
@@ -4206,8 +4206,8 @@
           </a:p>
         </p:txBody>
       </p:sp>
-      <mc:AlternateContent xmlns:mc="http://schemas.openxmlformats.org/markup-compatibility/2006">
-        <mc:Choice xmlns:a14="http://schemas.microsoft.com/office/drawing/2010/main" Requires="a14">
+      <mc:AlternateContent xmlns:mc="http://schemas.openxmlformats.org/markup-compatibility/2006" xmlns:a14="http://schemas.microsoft.com/office/drawing/2010/main">
+        <mc:Choice Requires="a14">
           <p:sp>
             <p:nvSpPr>
               <p:cNvPr id="3" name="Content Placeholder 2">
@@ -4399,7 +4399,7 @@
             </p:txBody>
           </p:sp>
         </mc:Choice>
-        <mc:Fallback>
+        <mc:Fallback xmlns="">
           <p:sp>
             <p:nvSpPr>
               <p:cNvPr id="3" name="Content Placeholder 2">
@@ -4501,8 +4501,13 @@
             </a:br>
             <a:r>
               <a:rPr lang="en-US" dirty="0"/>
-              <a:t>&amp; Variational Quantum Eigen Solver</a:t>
-            </a:r>
+              <a:t>&amp; Variational Quantum </a:t>
+            </a:r>
+            <a:r>
+              <a:rPr lang="en-US"/>
+              <a:t>Eigensolver</a:t>
+            </a:r>
+            <a:endParaRPr lang="en-US" dirty="0"/>
           </a:p>
         </p:txBody>
       </p:sp>
@@ -6595,8 +6600,8 @@
           </a:p>
         </p:txBody>
       </p:sp>
-      <mc:AlternateContent xmlns:mc="http://schemas.openxmlformats.org/markup-compatibility/2006">
-        <mc:Choice xmlns:a14="http://schemas.microsoft.com/office/drawing/2010/main" Requires="a14">
+      <mc:AlternateContent xmlns:mc="http://schemas.openxmlformats.org/markup-compatibility/2006" xmlns:a14="http://schemas.microsoft.com/office/drawing/2010/main">
+        <mc:Choice Requires="a14">
           <p:sp>
             <p:nvSpPr>
               <p:cNvPr id="3" name="Content Placeholder 2">
@@ -7151,7 +7156,7 @@
             </p:txBody>
           </p:sp>
         </mc:Choice>
-        <mc:Fallback>
+        <mc:Fallback xmlns="">
           <p:sp>
             <p:nvSpPr>
               <p:cNvPr id="3" name="Content Placeholder 2">

</xml_diff>